<commit_message>
Add per-persona demo GIFs and embed in cheatsheet PPTX
Five 60-second animated GIFs (one per stereotyped audience) recorded
with `precc gif` from tailored demo scripts in demo/gif/:
  dev       — install + hook in action + savings report
  tech_vc   — 4-pillar architecture + hook timing + AES-256 + metrics
  biz_vc    — dollar savings story + scaling table + ROI report
  cto       — security architecture + zero-network + fail-open + procurement
  devrel    — wow moment + 98% stat + learning loop + open TOML skills

generate_cheatsheets.py updated to discover and embed each persona's GIF
(via python-pptx add_movie) into the lower-right area of the corresponding
slide. Both precc-cheatsheet-en.pptx and precc-cheatsheet-zh.pptx rebuilt.
</commit_message>
<xml_diff>
--- a/precc-cheatsheet-en.pptx
+++ b/precc-cheatsheet-en.pptx
@@ -4029,11 +4029,66 @@
           </a:p>
         </p:txBody>
       </p:sp>
+      <p:pic>
+        <p:nvPicPr>
+          <p:cNvPr id="27" name="dev-1772440049.gif">
+            <a:hlinkClick r:id="" action="ppaction://media"/>
+          </p:cNvPr>
+          <p:cNvPicPr>
+            <a:picLocks noChangeAspect="1"/>
+          </p:cNvPicPr>
+          <p:nvPr>
+            <a:videoFile r:link="rId3"/>
+            <p:extLst>
+              <p:ext uri="{DAA4B4D4-6D71-4841-9C94-3DE7FCFB9230}">
+                <p14:media xmlns:p14="http://schemas.microsoft.com/office/powerpoint/2010/main" r:embed="rId2"/>
+              </p:ext>
+            </p:extLst>
+          </p:nvPr>
+        </p:nvPicPr>
+        <p:blipFill>
+          <a:blip r:embed="rId4"/>
+          <a:stretch>
+            <a:fillRect/>
+          </a:stretch>
+        </p:blipFill>
+        <p:spPr>
+          <a:xfrm>
+            <a:off x="6309360" y="3749040"/>
+            <a:ext cx="4114800" cy="2560320"/>
+          </a:xfrm>
+          <a:prstGeom prst="rect">
+            <a:avLst/>
+          </a:prstGeom>
+        </p:spPr>
+      </p:pic>
     </p:spTree>
   </p:cSld>
   <p:clrMapOvr>
     <a:masterClrMapping/>
   </p:clrMapOvr>
+  <p:timing>
+    <p:tnLst>
+      <p:par>
+        <p:cTn id="1" dur="indefinite" restart="never" nodeType="tmRoot">
+          <p:childTnLst>
+            <p:video>
+              <p:cMediaNode vol="80000">
+                <p:cTn id="2" fill="hold" display="0">
+                  <p:stCondLst>
+                    <p:cond delay="indefinite"/>
+                  </p:stCondLst>
+                </p:cTn>
+                <p:tgtEl>
+                  <p:spTgt spid="27"/>
+                </p:tgtEl>
+              </p:cMediaNode>
+            </p:video>
+          </p:childTnLst>
+        </p:cTn>
+      </p:par>
+    </p:tnLst>
+  </p:timing>
 </p:sld>
 </file>
 
@@ -5051,11 +5106,66 @@
           </a:p>
         </p:txBody>
       </p:sp>
+      <p:pic>
+        <p:nvPicPr>
+          <p:cNvPr id="29" name="tech_vc-1772440081.gif">
+            <a:hlinkClick r:id="" action="ppaction://media"/>
+          </p:cNvPr>
+          <p:cNvPicPr>
+            <a:picLocks noChangeAspect="1"/>
+          </p:cNvPicPr>
+          <p:nvPr>
+            <a:videoFile r:link="rId3"/>
+            <p:extLst>
+              <p:ext uri="{DAA4B4D4-6D71-4841-9C94-3DE7FCFB9230}">
+                <p14:media xmlns:p14="http://schemas.microsoft.com/office/powerpoint/2010/main" r:embed="rId2"/>
+              </p:ext>
+            </p:extLst>
+          </p:nvPr>
+        </p:nvPicPr>
+        <p:blipFill>
+          <a:blip r:embed="rId4"/>
+          <a:stretch>
+            <a:fillRect/>
+          </a:stretch>
+        </p:blipFill>
+        <p:spPr>
+          <a:xfrm>
+            <a:off x="6309360" y="3749040"/>
+            <a:ext cx="4114800" cy="2560320"/>
+          </a:xfrm>
+          <a:prstGeom prst="rect">
+            <a:avLst/>
+          </a:prstGeom>
+        </p:spPr>
+      </p:pic>
     </p:spTree>
   </p:cSld>
   <p:clrMapOvr>
     <a:masterClrMapping/>
   </p:clrMapOvr>
+  <p:timing>
+    <p:tnLst>
+      <p:par>
+        <p:cTn id="1" dur="indefinite" restart="never" nodeType="tmRoot">
+          <p:childTnLst>
+            <p:video>
+              <p:cMediaNode vol="80000">
+                <p:cTn id="2" fill="hold" display="0">
+                  <p:stCondLst>
+                    <p:cond delay="indefinite"/>
+                  </p:stCondLst>
+                </p:cTn>
+                <p:tgtEl>
+                  <p:spTgt spid="29"/>
+                </p:tgtEl>
+              </p:cMediaNode>
+            </p:video>
+          </p:childTnLst>
+        </p:cTn>
+      </p:par>
+    </p:tnLst>
+  </p:timing>
 </p:sld>
 </file>
 
@@ -6073,11 +6183,66 @@
           </a:p>
         </p:txBody>
       </p:sp>
+      <p:pic>
+        <p:nvPicPr>
+          <p:cNvPr id="29" name="biz_vc-1772440081.gif">
+            <a:hlinkClick r:id="" action="ppaction://media"/>
+          </p:cNvPr>
+          <p:cNvPicPr>
+            <a:picLocks noChangeAspect="1"/>
+          </p:cNvPicPr>
+          <p:nvPr>
+            <a:videoFile r:link="rId3"/>
+            <p:extLst>
+              <p:ext uri="{DAA4B4D4-6D71-4841-9C94-3DE7FCFB9230}">
+                <p14:media xmlns:p14="http://schemas.microsoft.com/office/powerpoint/2010/main" r:embed="rId2"/>
+              </p:ext>
+            </p:extLst>
+          </p:nvPr>
+        </p:nvPicPr>
+        <p:blipFill>
+          <a:blip r:embed="rId4"/>
+          <a:stretch>
+            <a:fillRect/>
+          </a:stretch>
+        </p:blipFill>
+        <p:spPr>
+          <a:xfrm>
+            <a:off x="6309360" y="3749040"/>
+            <a:ext cx="4114800" cy="2560320"/>
+          </a:xfrm>
+          <a:prstGeom prst="rect">
+            <a:avLst/>
+          </a:prstGeom>
+        </p:spPr>
+      </p:pic>
     </p:spTree>
   </p:cSld>
   <p:clrMapOvr>
     <a:masterClrMapping/>
   </p:clrMapOvr>
+  <p:timing>
+    <p:tnLst>
+      <p:par>
+        <p:cTn id="1" dur="indefinite" restart="never" nodeType="tmRoot">
+          <p:childTnLst>
+            <p:video>
+              <p:cMediaNode vol="80000">
+                <p:cTn id="2" fill="hold" display="0">
+                  <p:stCondLst>
+                    <p:cond delay="indefinite"/>
+                  </p:stCondLst>
+                </p:cTn>
+                <p:tgtEl>
+                  <p:spTgt spid="29"/>
+                </p:tgtEl>
+              </p:cMediaNode>
+            </p:video>
+          </p:childTnLst>
+        </p:cTn>
+      </p:par>
+    </p:tnLst>
+  </p:timing>
 </p:sld>
 </file>
 
@@ -7162,11 +7327,66 @@
           </a:p>
         </p:txBody>
       </p:sp>
+      <p:pic>
+        <p:nvPicPr>
+          <p:cNvPr id="31" name="cto-1772440082.gif">
+            <a:hlinkClick r:id="" action="ppaction://media"/>
+          </p:cNvPr>
+          <p:cNvPicPr>
+            <a:picLocks noChangeAspect="1"/>
+          </p:cNvPicPr>
+          <p:nvPr>
+            <a:videoFile r:link="rId3"/>
+            <p:extLst>
+              <p:ext uri="{DAA4B4D4-6D71-4841-9C94-3DE7FCFB9230}">
+                <p14:media xmlns:p14="http://schemas.microsoft.com/office/powerpoint/2010/main" r:embed="rId2"/>
+              </p:ext>
+            </p:extLst>
+          </p:nvPr>
+        </p:nvPicPr>
+        <p:blipFill>
+          <a:blip r:embed="rId4"/>
+          <a:stretch>
+            <a:fillRect/>
+          </a:stretch>
+        </p:blipFill>
+        <p:spPr>
+          <a:xfrm>
+            <a:off x="6309360" y="3749040"/>
+            <a:ext cx="4114800" cy="2560320"/>
+          </a:xfrm>
+          <a:prstGeom prst="rect">
+            <a:avLst/>
+          </a:prstGeom>
+        </p:spPr>
+      </p:pic>
     </p:spTree>
   </p:cSld>
   <p:clrMapOvr>
     <a:masterClrMapping/>
   </p:clrMapOvr>
+  <p:timing>
+    <p:tnLst>
+      <p:par>
+        <p:cTn id="1" dur="indefinite" restart="never" nodeType="tmRoot">
+          <p:childTnLst>
+            <p:video>
+              <p:cMediaNode vol="80000">
+                <p:cTn id="2" fill="hold" display="0">
+                  <p:stCondLst>
+                    <p:cond delay="indefinite"/>
+                  </p:stCondLst>
+                </p:cTn>
+                <p:tgtEl>
+                  <p:spTgt spid="31"/>
+                </p:tgtEl>
+              </p:cMediaNode>
+            </p:video>
+          </p:childTnLst>
+        </p:cTn>
+      </p:par>
+    </p:tnLst>
+  </p:timing>
 </p:sld>
 </file>
 
@@ -8217,11 +8437,66 @@
           </a:p>
         </p:txBody>
       </p:sp>
+      <p:pic>
+        <p:nvPicPr>
+          <p:cNvPr id="30" name="devrel-1772440083.gif">
+            <a:hlinkClick r:id="" action="ppaction://media"/>
+          </p:cNvPr>
+          <p:cNvPicPr>
+            <a:picLocks noChangeAspect="1"/>
+          </p:cNvPicPr>
+          <p:nvPr>
+            <a:videoFile r:link="rId3"/>
+            <p:extLst>
+              <p:ext uri="{DAA4B4D4-6D71-4841-9C94-3DE7FCFB9230}">
+                <p14:media xmlns:p14="http://schemas.microsoft.com/office/powerpoint/2010/main" r:embed="rId2"/>
+              </p:ext>
+            </p:extLst>
+          </p:nvPr>
+        </p:nvPicPr>
+        <p:blipFill>
+          <a:blip r:embed="rId4"/>
+          <a:stretch>
+            <a:fillRect/>
+          </a:stretch>
+        </p:blipFill>
+        <p:spPr>
+          <a:xfrm>
+            <a:off x="6309360" y="3749040"/>
+            <a:ext cx="4114800" cy="2560320"/>
+          </a:xfrm>
+          <a:prstGeom prst="rect">
+            <a:avLst/>
+          </a:prstGeom>
+        </p:spPr>
+      </p:pic>
     </p:spTree>
   </p:cSld>
   <p:clrMapOvr>
     <a:masterClrMapping/>
   </p:clrMapOvr>
+  <p:timing>
+    <p:tnLst>
+      <p:par>
+        <p:cTn id="1" dur="indefinite" restart="never" nodeType="tmRoot">
+          <p:childTnLst>
+            <p:video>
+              <p:cMediaNode vol="80000">
+                <p:cTn id="2" fill="hold" display="0">
+                  <p:stCondLst>
+                    <p:cond delay="indefinite"/>
+                  </p:stCondLst>
+                </p:cTn>
+                <p:tgtEl>
+                  <p:spTgt spid="30"/>
+                </p:tgtEl>
+              </p:cMediaNode>
+            </p:video>
+          </p:childTnLst>
+        </p:cTn>
+      </p:par>
+    </p:tnLst>
+  </p:timing>
 </p:sld>
 </file>
 

</xml_diff>